<commit_message>
ship verified Uptime402 finalist evidence
</commit_message>
<xml_diff>
--- a/submission/Uptime402_Deck.pptx
+++ b/submission/Uptime402_Deck.pptx
@@ -2,21 +2,21 @@
 <file path=ppt/presentation.xml><?xml version="1.0" encoding="utf-8"?>
 <p:presentation xmlns:p="http://schemas.openxmlformats.org/presentationml/2006/main">
   <p:sldMasterIdLst>
-    <p:sldMasterId xmlns:r="http://schemas.openxmlformats.org/officeDocument/2006/relationships" id="2147483648" r:id="R8b77734d62e34d7a"/>
+    <p:sldMasterId xmlns:r="http://schemas.openxmlformats.org/officeDocument/2006/relationships" id="2147483648" r:id="R6c1f3e516feb4dfc"/>
   </p:sldMasterIdLst>
   <p:notesMasterIdLst>
-    <p:notesMasterId xmlns:r="http://schemas.openxmlformats.org/officeDocument/2006/relationships" r:id="R477ad433eeda45ec"/>
+    <p:notesMasterId xmlns:r="http://schemas.openxmlformats.org/officeDocument/2006/relationships" r:id="R71434858e4534035"/>
   </p:notesMasterIdLst>
   <p:sldIdLst>
-    <p:sldId xmlns:r="http://schemas.openxmlformats.org/officeDocument/2006/relationships" id="256" r:id="R0227cf90c3db45b6"/>
-    <p:sldId xmlns:r="http://schemas.openxmlformats.org/officeDocument/2006/relationships" id="257" r:id="R8a0fe6964e484d2c"/>
-    <p:sldId xmlns:r="http://schemas.openxmlformats.org/officeDocument/2006/relationships" id="258" r:id="R1e5c53c49f3d4aea"/>
-    <p:sldId xmlns:r="http://schemas.openxmlformats.org/officeDocument/2006/relationships" id="259" r:id="R0495053b2c2141c3"/>
-    <p:sldId xmlns:r="http://schemas.openxmlformats.org/officeDocument/2006/relationships" id="260" r:id="Ra3381832f0d34371"/>
-    <p:sldId xmlns:r="http://schemas.openxmlformats.org/officeDocument/2006/relationships" id="261" r:id="Rd160914c89e646ca"/>
-    <p:sldId xmlns:r="http://schemas.openxmlformats.org/officeDocument/2006/relationships" id="262" r:id="R95b7872457fa46b2"/>
-    <p:sldId xmlns:r="http://schemas.openxmlformats.org/officeDocument/2006/relationships" id="263" r:id="Raf2844a8426949c1"/>
-    <p:sldId xmlns:r="http://schemas.openxmlformats.org/officeDocument/2006/relationships" id="264" r:id="R68f31ef11ba241b3"/>
+    <p:sldId xmlns:r="http://schemas.openxmlformats.org/officeDocument/2006/relationships" id="256" r:id="R77f62fdbbc1a46f2"/>
+    <p:sldId xmlns:r="http://schemas.openxmlformats.org/officeDocument/2006/relationships" id="257" r:id="R7423c4e27f6e4df3"/>
+    <p:sldId xmlns:r="http://schemas.openxmlformats.org/officeDocument/2006/relationships" id="258" r:id="Re0a73092d0a8454f"/>
+    <p:sldId xmlns:r="http://schemas.openxmlformats.org/officeDocument/2006/relationships" id="259" r:id="Rd5d01d7e00bd43bb"/>
+    <p:sldId xmlns:r="http://schemas.openxmlformats.org/officeDocument/2006/relationships" id="260" r:id="R1c5b222f535e46d6"/>
+    <p:sldId xmlns:r="http://schemas.openxmlformats.org/officeDocument/2006/relationships" id="261" r:id="R4ca58d41dc1e4300"/>
+    <p:sldId xmlns:r="http://schemas.openxmlformats.org/officeDocument/2006/relationships" id="262" r:id="R894df5a5044c45b6"/>
+    <p:sldId xmlns:r="http://schemas.openxmlformats.org/officeDocument/2006/relationships" id="263" r:id="R837fcd857eb94985"/>
+    <p:sldId xmlns:r="http://schemas.openxmlformats.org/officeDocument/2006/relationships" id="264" r:id="R8d5ae358944e47a2"/>
   </p:sldIdLst>
   <p:sldSz cx="12192000" cy="6858000"/>
   <p:notesSz cx="6858000" cy="9144000"/>
@@ -1198,7 +1198,7 @@
   </p:cSld>
   <p:clrMap bg1="lt1" tx1="dk1" bg2="lt2" tx2="dk2" accent1="accent1" accent2="accent2" accent3="accent3" accent4="accent4" accent5="accent5" accent6="accent6" hlink="hlink" folHlink="folHlink"/>
   <p:sldLayoutIdLst>
-    <p:sldLayoutId xmlns:r="http://schemas.openxmlformats.org/officeDocument/2006/relationships" id="2147483649" r:id="R94f16684f13c42bf"/>
+    <p:sldLayoutId xmlns:r="http://schemas.openxmlformats.org/officeDocument/2006/relationships" id="2147483649" r:id="R572e26e82af04e0c"/>
   </p:sldLayoutIdLst>
   <p:txStyles>
     <p:titleStyle>
@@ -1808,6 +1808,7 @@
           <a:lstStyle xmlns:a="http://schemas.openxmlformats.org/drawingml/2006/main"/>
           <a:p xmlns:a="http://schemas.openxmlformats.org/drawingml/2006/main">
             <a:pPr algn="l">
+              <a:buNone/>
               <a:defRPr sz="1500" b="1">
                 <a:solidFill>
                   <a:srgbClr val="39D8FF"/>
@@ -1864,6 +1865,7 @@
           <a:lstStyle xmlns:a="http://schemas.openxmlformats.org/drawingml/2006/main"/>
           <a:p xmlns:a="http://schemas.openxmlformats.org/drawingml/2006/main">
             <a:pPr algn="l">
+              <a:buNone/>
               <a:defRPr sz="4350" b="1">
                 <a:solidFill>
                   <a:srgbClr val="F4F9FC"/>
@@ -1887,6 +1889,7 @@
           </a:p>
           <a:p xmlns:a="http://schemas.openxmlformats.org/drawingml/2006/main">
             <a:pPr algn="l">
+              <a:buNone/>
               <a:defRPr sz="4350" b="1">
                 <a:solidFill>
                   <a:srgbClr val="F4F9FC"/>
@@ -1943,6 +1946,7 @@
           <a:lstStyle xmlns:a="http://schemas.openxmlformats.org/drawingml/2006/main"/>
           <a:p xmlns:a="http://schemas.openxmlformats.org/drawingml/2006/main">
             <a:pPr algn="l">
+              <a:buNone/>
               <a:defRPr sz="1800" b="0">
                 <a:solidFill>
                   <a:srgbClr val="8FA8BA"/>
@@ -1999,6 +2003,7 @@
           <a:lstStyle xmlns:a="http://schemas.openxmlformats.org/drawingml/2006/main"/>
           <a:p xmlns:a="http://schemas.openxmlformats.org/drawingml/2006/main">
             <a:pPr algn="l">
+              <a:buNone/>
               <a:defRPr sz="1350" b="1">
                 <a:solidFill>
                   <a:srgbClr val="46E6A6"/>
@@ -2055,6 +2060,7 @@
           <a:lstStyle xmlns:a="http://schemas.openxmlformats.org/drawingml/2006/main"/>
           <a:p xmlns:a="http://schemas.openxmlformats.org/drawingml/2006/main">
             <a:pPr algn="r">
+              <a:buNone/>
               <a:defRPr sz="3000" b="1">
                 <a:solidFill>
                   <a:srgbClr val="274055"/>
@@ -2140,6 +2146,7 @@
           <a:lstStyle xmlns:a="http://schemas.openxmlformats.org/drawingml/2006/main"/>
           <a:p xmlns:a="http://schemas.openxmlformats.org/drawingml/2006/main">
             <a:pPr algn="l">
+              <a:buNone/>
               <a:defRPr sz="975" b="1">
                 <a:solidFill>
                   <a:srgbClr val="8FA8BA"/>
@@ -2196,6 +2203,7 @@
           <a:lstStyle xmlns:a="http://schemas.openxmlformats.org/drawingml/2006/main"/>
           <a:p xmlns:a="http://schemas.openxmlformats.org/drawingml/2006/main">
             <a:pPr algn="l">
+              <a:buNone/>
               <a:defRPr sz="975" b="1">
                 <a:solidFill>
                   <a:srgbClr val="39D8FF"/>
@@ -2283,6 +2291,7 @@
           <a:lstStyle xmlns:a="http://schemas.openxmlformats.org/drawingml/2006/main"/>
           <a:p xmlns:a="http://schemas.openxmlformats.org/drawingml/2006/main">
             <a:pPr algn="l">
+              <a:buNone/>
               <a:defRPr sz="750" b="0">
                 <a:solidFill>
                   <a:srgbClr val="8FA8BA"/>
@@ -2339,6 +2348,7 @@
           <a:lstStyle xmlns:a="http://schemas.openxmlformats.org/drawingml/2006/main"/>
           <a:p xmlns:a="http://schemas.openxmlformats.org/drawingml/2006/main">
             <a:pPr algn="r">
+              <a:buNone/>
               <a:defRPr sz="750" b="0">
                 <a:solidFill>
                   <a:srgbClr val="8FA8BA"/>
@@ -2395,6 +2405,7 @@
           <a:lstStyle xmlns:a="http://schemas.openxmlformats.org/drawingml/2006/main"/>
           <a:p xmlns:a="http://schemas.openxmlformats.org/drawingml/2006/main">
             <a:pPr algn="l">
+              <a:buNone/>
               <a:defRPr sz="3225" b="1">
                 <a:solidFill>
                   <a:srgbClr val="F4F9FC"/>
@@ -2418,6 +2429,7 @@
           </a:p>
           <a:p xmlns:a="http://schemas.openxmlformats.org/drawingml/2006/main">
             <a:pPr algn="l">
+              <a:buNone/>
               <a:defRPr sz="3225" b="1">
                 <a:solidFill>
                   <a:srgbClr val="F4F9FC"/>
@@ -2474,6 +2486,7 @@
           <a:lstStyle xmlns:a="http://schemas.openxmlformats.org/drawingml/2006/main"/>
           <a:p xmlns:a="http://schemas.openxmlformats.org/drawingml/2006/main">
             <a:pPr algn="l">
+              <a:buNone/>
               <a:defRPr sz="1575" b="0">
                 <a:solidFill>
                   <a:srgbClr val="8FA8BA"/>
@@ -2594,6 +2607,7 @@
           <a:lstStyle xmlns:a="http://schemas.openxmlformats.org/drawingml/2006/main"/>
           <a:p xmlns:a="http://schemas.openxmlformats.org/drawingml/2006/main">
             <a:pPr algn="l">
+              <a:buNone/>
               <a:defRPr sz="1050" b="1">
                 <a:solidFill>
                   <a:srgbClr val="8FA8BA"/>
@@ -2650,6 +2664,7 @@
           <a:lstStyle xmlns:a="http://schemas.openxmlformats.org/drawingml/2006/main"/>
           <a:p xmlns:a="http://schemas.openxmlformats.org/drawingml/2006/main">
             <a:pPr algn="l">
+              <a:buNone/>
               <a:defRPr sz="1875" b="1">
                 <a:solidFill>
                   <a:srgbClr val="F4F9FC"/>
@@ -2706,6 +2721,7 @@
           <a:lstStyle xmlns:a="http://schemas.openxmlformats.org/drawingml/2006/main"/>
           <a:p xmlns:a="http://schemas.openxmlformats.org/drawingml/2006/main">
             <a:pPr algn="l">
+              <a:buNone/>
               <a:defRPr sz="1200" b="0">
                 <a:solidFill>
                   <a:srgbClr val="8FA8BA"/>
@@ -2795,6 +2811,7 @@
           <a:lstStyle xmlns:a="http://schemas.openxmlformats.org/drawingml/2006/main"/>
           <a:p xmlns:a="http://schemas.openxmlformats.org/drawingml/2006/main">
             <a:pPr algn="l">
+              <a:buNone/>
               <a:defRPr sz="1050" b="1">
                 <a:solidFill>
                   <a:srgbClr val="8FA8BA"/>
@@ -2851,6 +2868,7 @@
           <a:lstStyle xmlns:a="http://schemas.openxmlformats.org/drawingml/2006/main"/>
           <a:p xmlns:a="http://schemas.openxmlformats.org/drawingml/2006/main">
             <a:pPr algn="l">
+              <a:buNone/>
               <a:defRPr sz="1875" b="1">
                 <a:solidFill>
                   <a:srgbClr val="F4F9FC"/>
@@ -2907,6 +2925,7 @@
           <a:lstStyle xmlns:a="http://schemas.openxmlformats.org/drawingml/2006/main"/>
           <a:p xmlns:a="http://schemas.openxmlformats.org/drawingml/2006/main">
             <a:pPr algn="l">
+              <a:buNone/>
               <a:defRPr sz="1200" b="0">
                 <a:solidFill>
                   <a:srgbClr val="8FA8BA"/>
@@ -2996,6 +3015,7 @@
           <a:lstStyle xmlns:a="http://schemas.openxmlformats.org/drawingml/2006/main"/>
           <a:p xmlns:a="http://schemas.openxmlformats.org/drawingml/2006/main">
             <a:pPr algn="l">
+              <a:buNone/>
               <a:defRPr sz="1050" b="1">
                 <a:solidFill>
                   <a:srgbClr val="8FA8BA"/>
@@ -3052,6 +3072,7 @@
           <a:lstStyle xmlns:a="http://schemas.openxmlformats.org/drawingml/2006/main"/>
           <a:p xmlns:a="http://schemas.openxmlformats.org/drawingml/2006/main">
             <a:pPr algn="l">
+              <a:buNone/>
               <a:defRPr sz="1875" b="1">
                 <a:solidFill>
                   <a:srgbClr val="FF5C75"/>
@@ -3108,6 +3129,7 @@
           <a:lstStyle xmlns:a="http://schemas.openxmlformats.org/drawingml/2006/main"/>
           <a:p xmlns:a="http://schemas.openxmlformats.org/drawingml/2006/main">
             <a:pPr algn="l">
+              <a:buNone/>
               <a:defRPr sz="1200" b="0">
                 <a:solidFill>
                   <a:srgbClr val="8FA8BA"/>
@@ -3197,6 +3219,7 @@
           <a:lstStyle xmlns:a="http://schemas.openxmlformats.org/drawingml/2006/main"/>
           <a:p xmlns:a="http://schemas.openxmlformats.org/drawingml/2006/main">
             <a:pPr algn="l">
+              <a:buNone/>
               <a:defRPr sz="1050" b="1">
                 <a:solidFill>
                   <a:srgbClr val="8FA8BA"/>
@@ -3253,6 +3276,7 @@
           <a:lstStyle xmlns:a="http://schemas.openxmlformats.org/drawingml/2006/main"/>
           <a:p xmlns:a="http://schemas.openxmlformats.org/drawingml/2006/main">
             <a:pPr algn="l">
+              <a:buNone/>
               <a:defRPr sz="1875" b="1">
                 <a:solidFill>
                   <a:srgbClr val="F4F9FC"/>
@@ -3309,6 +3333,7 @@
           <a:lstStyle xmlns:a="http://schemas.openxmlformats.org/drawingml/2006/main"/>
           <a:p xmlns:a="http://schemas.openxmlformats.org/drawingml/2006/main">
             <a:pPr algn="l">
+              <a:buNone/>
               <a:defRPr sz="1200" b="0">
                 <a:solidFill>
                   <a:srgbClr val="8FA8BA"/>
@@ -3394,6 +3419,7 @@
           <a:lstStyle xmlns:a="http://schemas.openxmlformats.org/drawingml/2006/main"/>
           <a:p xmlns:a="http://schemas.openxmlformats.org/drawingml/2006/main">
             <a:pPr algn="l">
+              <a:buNone/>
               <a:defRPr sz="975" b="1">
                 <a:solidFill>
                   <a:srgbClr val="8FA8BA"/>
@@ -3450,6 +3476,7 @@
           <a:lstStyle xmlns:a="http://schemas.openxmlformats.org/drawingml/2006/main"/>
           <a:p xmlns:a="http://schemas.openxmlformats.org/drawingml/2006/main">
             <a:pPr algn="l">
+              <a:buNone/>
               <a:defRPr sz="975" b="1">
                 <a:solidFill>
                   <a:srgbClr val="39D8FF"/>
@@ -3537,6 +3564,7 @@
           <a:lstStyle xmlns:a="http://schemas.openxmlformats.org/drawingml/2006/main"/>
           <a:p xmlns:a="http://schemas.openxmlformats.org/drawingml/2006/main">
             <a:pPr algn="l">
+              <a:buNone/>
               <a:defRPr sz="750" b="0">
                 <a:solidFill>
                   <a:srgbClr val="8FA8BA"/>
@@ -3593,6 +3621,7 @@
           <a:lstStyle xmlns:a="http://schemas.openxmlformats.org/drawingml/2006/main"/>
           <a:p xmlns:a="http://schemas.openxmlformats.org/drawingml/2006/main">
             <a:pPr algn="r">
+              <a:buNone/>
               <a:defRPr sz="750" b="0">
                 <a:solidFill>
                   <a:srgbClr val="8FA8BA"/>
@@ -3649,6 +3678,7 @@
           <a:lstStyle xmlns:a="http://schemas.openxmlformats.org/drawingml/2006/main"/>
           <a:p xmlns:a="http://schemas.openxmlformats.org/drawingml/2006/main">
             <a:pPr algn="l">
+              <a:buNone/>
               <a:defRPr sz="3150" b="1">
                 <a:solidFill>
                   <a:srgbClr val="F4F9FC"/>
@@ -3672,6 +3702,7 @@
           </a:p>
           <a:p xmlns:a="http://schemas.openxmlformats.org/drawingml/2006/main">
             <a:pPr algn="l">
+              <a:buNone/>
               <a:defRPr sz="3150" b="1">
                 <a:solidFill>
                   <a:srgbClr val="F4F9FC"/>
@@ -3728,6 +3759,7 @@
           <a:lstStyle xmlns:a="http://schemas.openxmlformats.org/drawingml/2006/main"/>
           <a:p xmlns:a="http://schemas.openxmlformats.org/drawingml/2006/main">
             <a:pPr algn="l">
+              <a:buNone/>
               <a:defRPr sz="11700" b="1">
                 <a:solidFill>
                   <a:srgbClr val="46E6A6"/>
@@ -3784,6 +3816,7 @@
           <a:lstStyle xmlns:a="http://schemas.openxmlformats.org/drawingml/2006/main"/>
           <a:p xmlns:a="http://schemas.openxmlformats.org/drawingml/2006/main">
             <a:pPr algn="l">
+              <a:buNone/>
               <a:defRPr sz="1875" b="1">
                 <a:solidFill>
                   <a:srgbClr val="F4F9FC"/>
@@ -3807,6 +3840,7 @@
           </a:p>
           <a:p xmlns:a="http://schemas.openxmlformats.org/drawingml/2006/main">
             <a:pPr algn="l">
+              <a:buNone/>
               <a:defRPr sz="1875" b="1">
                 <a:solidFill>
                   <a:srgbClr val="F4F9FC"/>
@@ -3894,6 +3928,7 @@
           <a:lstStyle xmlns:a="http://schemas.openxmlformats.org/drawingml/2006/main"/>
           <a:p xmlns:a="http://schemas.openxmlformats.org/drawingml/2006/main">
             <a:pPr algn="l">
+              <a:buNone/>
               <a:defRPr sz="975" b="1">
                 <a:solidFill>
                   <a:srgbClr val="FFBC5B"/>
@@ -3950,6 +3985,7 @@
           <a:lstStyle xmlns:a="http://schemas.openxmlformats.org/drawingml/2006/main"/>
           <a:p xmlns:a="http://schemas.openxmlformats.org/drawingml/2006/main">
             <a:pPr algn="l">
+              <a:buNone/>
               <a:defRPr sz="1875" b="1">
                 <a:solidFill>
                   <a:srgbClr val="F4F9FC"/>
@@ -4037,6 +4073,7 @@
           <a:lstStyle xmlns:a="http://schemas.openxmlformats.org/drawingml/2006/main"/>
           <a:p xmlns:a="http://schemas.openxmlformats.org/drawingml/2006/main">
             <a:pPr algn="l">
+              <a:buNone/>
               <a:defRPr sz="975" b="1">
                 <a:solidFill>
                   <a:srgbClr val="FFBC5B"/>
@@ -4093,6 +4130,7 @@
           <a:lstStyle xmlns:a="http://schemas.openxmlformats.org/drawingml/2006/main"/>
           <a:p xmlns:a="http://schemas.openxmlformats.org/drawingml/2006/main">
             <a:pPr algn="l">
+              <a:buNone/>
               <a:defRPr sz="1875" b="1">
                 <a:solidFill>
                   <a:srgbClr val="F4F9FC"/>
@@ -4180,6 +4218,7 @@
           <a:lstStyle xmlns:a="http://schemas.openxmlformats.org/drawingml/2006/main"/>
           <a:p xmlns:a="http://schemas.openxmlformats.org/drawingml/2006/main">
             <a:pPr algn="l">
+              <a:buNone/>
               <a:defRPr sz="975" b="1">
                 <a:solidFill>
                   <a:srgbClr val="FFBC5B"/>
@@ -4236,6 +4275,7 @@
           <a:lstStyle xmlns:a="http://schemas.openxmlformats.org/drawingml/2006/main"/>
           <a:p xmlns:a="http://schemas.openxmlformats.org/drawingml/2006/main">
             <a:pPr algn="l">
+              <a:buNone/>
               <a:defRPr sz="1875" b="1">
                 <a:solidFill>
                   <a:srgbClr val="F4F9FC"/>
@@ -4323,6 +4363,7 @@
           <a:lstStyle xmlns:a="http://schemas.openxmlformats.org/drawingml/2006/main"/>
           <a:p xmlns:a="http://schemas.openxmlformats.org/drawingml/2006/main">
             <a:pPr algn="l">
+              <a:buNone/>
               <a:defRPr sz="975" b="1">
                 <a:solidFill>
                   <a:srgbClr val="FFBC5B"/>
@@ -4379,6 +4420,7 @@
           <a:lstStyle xmlns:a="http://schemas.openxmlformats.org/drawingml/2006/main"/>
           <a:p xmlns:a="http://schemas.openxmlformats.org/drawingml/2006/main">
             <a:pPr algn="l">
+              <a:buNone/>
               <a:defRPr sz="1875" b="1">
                 <a:solidFill>
                   <a:srgbClr val="F4F9FC"/>
@@ -4466,6 +4508,7 @@
           <a:lstStyle xmlns:a="http://schemas.openxmlformats.org/drawingml/2006/main"/>
           <a:p xmlns:a="http://schemas.openxmlformats.org/drawingml/2006/main">
             <a:pPr algn="l">
+              <a:buNone/>
               <a:defRPr sz="975" b="1">
                 <a:solidFill>
                   <a:srgbClr val="FFBC5B"/>
@@ -4522,6 +4565,7 @@
           <a:lstStyle xmlns:a="http://schemas.openxmlformats.org/drawingml/2006/main"/>
           <a:p xmlns:a="http://schemas.openxmlformats.org/drawingml/2006/main">
             <a:pPr algn="l">
+              <a:buNone/>
               <a:defRPr sz="1875" b="1">
                 <a:solidFill>
                   <a:srgbClr val="F4F9FC"/>
@@ -4578,6 +4622,7 @@
           <a:lstStyle xmlns:a="http://schemas.openxmlformats.org/drawingml/2006/main"/>
           <a:p xmlns:a="http://schemas.openxmlformats.org/drawingml/2006/main">
             <a:pPr algn="l">
+              <a:buNone/>
               <a:defRPr sz="1200" b="1">
                 <a:solidFill>
                   <a:srgbClr val="FFBC5B"/>
@@ -4663,6 +4708,7 @@
           <a:lstStyle xmlns:a="http://schemas.openxmlformats.org/drawingml/2006/main"/>
           <a:p xmlns:a="http://schemas.openxmlformats.org/drawingml/2006/main">
             <a:pPr algn="l">
+              <a:buNone/>
               <a:defRPr sz="975" b="1">
                 <a:solidFill>
                   <a:srgbClr val="8FA8BA"/>
@@ -4719,6 +4765,7 @@
           <a:lstStyle xmlns:a="http://schemas.openxmlformats.org/drawingml/2006/main"/>
           <a:p xmlns:a="http://schemas.openxmlformats.org/drawingml/2006/main">
             <a:pPr algn="l">
+              <a:buNone/>
               <a:defRPr sz="975" b="1">
                 <a:solidFill>
                   <a:srgbClr val="39D8FF"/>
@@ -4806,6 +4853,7 @@
           <a:lstStyle xmlns:a="http://schemas.openxmlformats.org/drawingml/2006/main"/>
           <a:p xmlns:a="http://schemas.openxmlformats.org/drawingml/2006/main">
             <a:pPr algn="l">
+              <a:buNone/>
               <a:defRPr sz="750" b="0">
                 <a:solidFill>
                   <a:srgbClr val="8FA8BA"/>
@@ -4862,6 +4910,7 @@
           <a:lstStyle xmlns:a="http://schemas.openxmlformats.org/drawingml/2006/main"/>
           <a:p xmlns:a="http://schemas.openxmlformats.org/drawingml/2006/main">
             <a:pPr algn="r">
+              <a:buNone/>
               <a:defRPr sz="750" b="0">
                 <a:solidFill>
                   <a:srgbClr val="8FA8BA"/>
@@ -4918,6 +4967,7 @@
           <a:lstStyle xmlns:a="http://schemas.openxmlformats.org/drawingml/2006/main"/>
           <a:p xmlns:a="http://schemas.openxmlformats.org/drawingml/2006/main">
             <a:pPr algn="l">
+              <a:buNone/>
               <a:defRPr sz="3000" b="1">
                 <a:solidFill>
                   <a:srgbClr val="F4F9FC"/>
@@ -4974,6 +5024,7 @@
           <a:lstStyle xmlns:a="http://schemas.openxmlformats.org/drawingml/2006/main"/>
           <a:p xmlns:a="http://schemas.openxmlformats.org/drawingml/2006/main">
             <a:pPr algn="l">
+              <a:buNone/>
               <a:defRPr sz="1500" b="0">
                 <a:solidFill>
                   <a:srgbClr val="8FA8BA"/>
@@ -5280,6 +5331,7 @@
           <a:lstStyle xmlns:a="http://schemas.openxmlformats.org/drawingml/2006/main"/>
           <a:p xmlns:a="http://schemas.openxmlformats.org/drawingml/2006/main">
             <a:pPr algn="ctr">
+              <a:buNone/>
               <a:defRPr sz="1125" b="1">
                 <a:solidFill>
                   <a:srgbClr val="39D8FF"/>
@@ -5369,6 +5421,7 @@
           <a:lstStyle xmlns:a="http://schemas.openxmlformats.org/drawingml/2006/main"/>
           <a:p xmlns:a="http://schemas.openxmlformats.org/drawingml/2006/main">
             <a:pPr algn="ctr">
+              <a:buNone/>
               <a:defRPr sz="1125" b="1">
                 <a:solidFill>
                   <a:srgbClr val="FF5C75"/>
@@ -5458,6 +5511,7 @@
           <a:lstStyle xmlns:a="http://schemas.openxmlformats.org/drawingml/2006/main"/>
           <a:p xmlns:a="http://schemas.openxmlformats.org/drawingml/2006/main">
             <a:pPr algn="ctr">
+              <a:buNone/>
               <a:defRPr sz="1125" b="1">
                 <a:solidFill>
                   <a:srgbClr val="FFBC5B"/>
@@ -5547,6 +5601,7 @@
           <a:lstStyle xmlns:a="http://schemas.openxmlformats.org/drawingml/2006/main"/>
           <a:p xmlns:a="http://schemas.openxmlformats.org/drawingml/2006/main">
             <a:pPr algn="ctr">
+              <a:buNone/>
               <a:defRPr sz="1125" b="1">
                 <a:solidFill>
                   <a:srgbClr val="FFBC5B"/>
@@ -5636,6 +5691,7 @@
           <a:lstStyle xmlns:a="http://schemas.openxmlformats.org/drawingml/2006/main"/>
           <a:p xmlns:a="http://schemas.openxmlformats.org/drawingml/2006/main">
             <a:pPr algn="ctr">
+              <a:buNone/>
               <a:defRPr sz="1125" b="1">
                 <a:solidFill>
                   <a:srgbClr val="39D8FF"/>
@@ -5725,6 +5781,7 @@
           <a:lstStyle xmlns:a="http://schemas.openxmlformats.org/drawingml/2006/main"/>
           <a:p xmlns:a="http://schemas.openxmlformats.org/drawingml/2006/main">
             <a:pPr algn="ctr">
+              <a:buNone/>
               <a:defRPr sz="1125" b="1">
                 <a:solidFill>
                   <a:srgbClr val="39D8FF"/>
@@ -5814,6 +5871,7 @@
           <a:lstStyle xmlns:a="http://schemas.openxmlformats.org/drawingml/2006/main"/>
           <a:p xmlns:a="http://schemas.openxmlformats.org/drawingml/2006/main">
             <a:pPr algn="ctr">
+              <a:buNone/>
               <a:defRPr sz="1125" b="1">
                 <a:solidFill>
                   <a:srgbClr val="46E6A6"/>
@@ -5903,6 +5961,7 @@
           <a:lstStyle xmlns:a="http://schemas.openxmlformats.org/drawingml/2006/main"/>
           <a:p xmlns:a="http://schemas.openxmlformats.org/drawingml/2006/main">
             <a:pPr algn="ctr">
+              <a:buNone/>
               <a:defRPr sz="1125" b="1">
                 <a:solidFill>
                   <a:srgbClr val="46E6A6"/>
@@ -5959,6 +6018,7 @@
           <a:lstStyle xmlns:a="http://schemas.openxmlformats.org/drawingml/2006/main"/>
           <a:p xmlns:a="http://schemas.openxmlformats.org/drawingml/2006/main">
             <a:pPr algn="l">
+              <a:buNone/>
               <a:defRPr sz="1350" b="1">
                 <a:solidFill>
                   <a:srgbClr val="FF5C75"/>
@@ -6015,6 +6075,7 @@
           <a:lstStyle xmlns:a="http://schemas.openxmlformats.org/drawingml/2006/main"/>
           <a:p xmlns:a="http://schemas.openxmlformats.org/drawingml/2006/main">
             <a:pPr algn="l">
+              <a:buNone/>
               <a:defRPr sz="1350" b="1">
                 <a:solidFill>
                   <a:srgbClr val="FFBC5B"/>
@@ -6071,6 +6132,7 @@
           <a:lstStyle xmlns:a="http://schemas.openxmlformats.org/drawingml/2006/main"/>
           <a:p xmlns:a="http://schemas.openxmlformats.org/drawingml/2006/main">
             <a:pPr algn="l">
+              <a:buNone/>
               <a:defRPr sz="1350" b="1">
                 <a:solidFill>
                   <a:srgbClr val="46E6A6"/>
@@ -6127,6 +6189,7 @@
           <a:lstStyle xmlns:a="http://schemas.openxmlformats.org/drawingml/2006/main"/>
           <a:p xmlns:a="http://schemas.openxmlformats.org/drawingml/2006/main">
             <a:pPr algn="ctr">
+              <a:buNone/>
               <a:defRPr sz="1500" b="1">
                 <a:solidFill>
                   <a:srgbClr val="F4F9FC"/>
@@ -6212,6 +6275,7 @@
           <a:lstStyle xmlns:a="http://schemas.openxmlformats.org/drawingml/2006/main"/>
           <a:p xmlns:a="http://schemas.openxmlformats.org/drawingml/2006/main">
             <a:pPr algn="l">
+              <a:buNone/>
               <a:defRPr sz="975" b="1">
                 <a:solidFill>
                   <a:srgbClr val="8FA8BA"/>
@@ -6268,6 +6332,7 @@
           <a:lstStyle xmlns:a="http://schemas.openxmlformats.org/drawingml/2006/main"/>
           <a:p xmlns:a="http://schemas.openxmlformats.org/drawingml/2006/main">
             <a:pPr algn="l">
+              <a:buNone/>
               <a:defRPr sz="975" b="1">
                 <a:solidFill>
                   <a:srgbClr val="39D8FF"/>
@@ -6355,6 +6420,7 @@
           <a:lstStyle xmlns:a="http://schemas.openxmlformats.org/drawingml/2006/main"/>
           <a:p xmlns:a="http://schemas.openxmlformats.org/drawingml/2006/main">
             <a:pPr algn="l">
+              <a:buNone/>
               <a:defRPr sz="750" b="0">
                 <a:solidFill>
                   <a:srgbClr val="8FA8BA"/>
@@ -6411,6 +6477,7 @@
           <a:lstStyle xmlns:a="http://schemas.openxmlformats.org/drawingml/2006/main"/>
           <a:p xmlns:a="http://schemas.openxmlformats.org/drawingml/2006/main">
             <a:pPr algn="r">
+              <a:buNone/>
               <a:defRPr sz="750" b="0">
                 <a:solidFill>
                   <a:srgbClr val="8FA8BA"/>
@@ -6467,6 +6534,7 @@
           <a:lstStyle xmlns:a="http://schemas.openxmlformats.org/drawingml/2006/main"/>
           <a:p xmlns:a="http://schemas.openxmlformats.org/drawingml/2006/main">
             <a:pPr algn="l">
+              <a:buNone/>
               <a:defRPr sz="3150" b="1">
                 <a:solidFill>
                   <a:srgbClr val="F4F9FC"/>
@@ -6523,6 +6591,7 @@
           <a:lstStyle xmlns:a="http://schemas.openxmlformats.org/drawingml/2006/main"/>
           <a:p xmlns:a="http://schemas.openxmlformats.org/drawingml/2006/main">
             <a:pPr algn="l">
+              <a:buNone/>
               <a:defRPr sz="1500" b="0">
                 <a:solidFill>
                   <a:srgbClr val="8FA8BA"/>
@@ -6707,6 +6776,7 @@
           <a:lstStyle xmlns:a="http://schemas.openxmlformats.org/drawingml/2006/main"/>
           <a:p xmlns:a="http://schemas.openxmlformats.org/drawingml/2006/main">
             <a:pPr algn="ctr">
+              <a:buNone/>
               <a:defRPr sz="1200" b="1">
                 <a:solidFill>
                   <a:srgbClr val="39D8FF"/>
@@ -6794,6 +6864,7 @@
           <a:lstStyle xmlns:a="http://schemas.openxmlformats.org/drawingml/2006/main"/>
           <a:p xmlns:a="http://schemas.openxmlformats.org/drawingml/2006/main">
             <a:pPr algn="ctr">
+              <a:buNone/>
               <a:defRPr sz="1425" b="0">
                 <a:solidFill>
                   <a:srgbClr val="F4F9FC"/>
@@ -6817,6 +6888,7 @@
           </a:p>
           <a:p xmlns:a="http://schemas.openxmlformats.org/drawingml/2006/main">
             <a:pPr algn="ctr">
+              <a:buNone/>
               <a:defRPr sz="1425" b="0">
                 <a:solidFill>
                   <a:srgbClr val="F4F9FC"/>
@@ -6840,6 +6912,7 @@
           </a:p>
           <a:p xmlns:a="http://schemas.openxmlformats.org/drawingml/2006/main">
             <a:pPr algn="ctr">
+              <a:buNone/>
               <a:defRPr sz="1425" b="0">
                 <a:solidFill>
                   <a:srgbClr val="F4F9FC"/>
@@ -6863,6 +6936,7 @@
           </a:p>
           <a:p xmlns:a="http://schemas.openxmlformats.org/drawingml/2006/main">
             <a:pPr algn="ctr">
+              <a:buNone/>
               <a:defRPr sz="1425" b="0">
                 <a:solidFill>
                   <a:srgbClr val="F4F9FC"/>
@@ -6954,6 +7028,7 @@
           <a:lstStyle xmlns:a="http://schemas.openxmlformats.org/drawingml/2006/main"/>
           <a:p xmlns:a="http://schemas.openxmlformats.org/drawingml/2006/main">
             <a:pPr algn="ctr">
+              <a:buNone/>
               <a:defRPr sz="1200" b="1">
                 <a:solidFill>
                   <a:srgbClr val="FFBC5B"/>
@@ -7041,6 +7116,7 @@
           <a:lstStyle xmlns:a="http://schemas.openxmlformats.org/drawingml/2006/main"/>
           <a:p xmlns:a="http://schemas.openxmlformats.org/drawingml/2006/main">
             <a:pPr algn="ctr">
+              <a:buNone/>
               <a:defRPr sz="1425" b="0">
                 <a:solidFill>
                   <a:srgbClr val="F4F9FC"/>
@@ -7064,6 +7140,7 @@
           </a:p>
           <a:p xmlns:a="http://schemas.openxmlformats.org/drawingml/2006/main">
             <a:pPr algn="ctr">
+              <a:buNone/>
               <a:defRPr sz="1425" b="0">
                 <a:solidFill>
                   <a:srgbClr val="F4F9FC"/>
@@ -7087,6 +7164,7 @@
           </a:p>
           <a:p xmlns:a="http://schemas.openxmlformats.org/drawingml/2006/main">
             <a:pPr algn="ctr">
+              <a:buNone/>
               <a:defRPr sz="1425" b="0">
                 <a:solidFill>
                   <a:srgbClr val="F4F9FC"/>
@@ -7110,6 +7188,7 @@
           </a:p>
           <a:p xmlns:a="http://schemas.openxmlformats.org/drawingml/2006/main">
             <a:pPr algn="ctr">
+              <a:buNone/>
               <a:defRPr sz="1425" b="0">
                 <a:solidFill>
                   <a:srgbClr val="F4F9FC"/>
@@ -7201,6 +7280,7 @@
           <a:lstStyle xmlns:a="http://schemas.openxmlformats.org/drawingml/2006/main"/>
           <a:p xmlns:a="http://schemas.openxmlformats.org/drawingml/2006/main">
             <a:pPr algn="ctr">
+              <a:buNone/>
               <a:defRPr sz="1200" b="1">
                 <a:solidFill>
                   <a:srgbClr val="46E6A6"/>
@@ -7288,6 +7368,7 @@
           <a:lstStyle xmlns:a="http://schemas.openxmlformats.org/drawingml/2006/main"/>
           <a:p xmlns:a="http://schemas.openxmlformats.org/drawingml/2006/main">
             <a:pPr algn="ctr">
+              <a:buNone/>
               <a:defRPr sz="1425" b="0">
                 <a:solidFill>
                   <a:srgbClr val="F4F9FC"/>
@@ -7311,6 +7392,7 @@
           </a:p>
           <a:p xmlns:a="http://schemas.openxmlformats.org/drawingml/2006/main">
             <a:pPr algn="ctr">
+              <a:buNone/>
               <a:defRPr sz="1425" b="0">
                 <a:solidFill>
                   <a:srgbClr val="F4F9FC"/>
@@ -7334,6 +7416,7 @@
           </a:p>
           <a:p xmlns:a="http://schemas.openxmlformats.org/drawingml/2006/main">
             <a:pPr algn="ctr">
+              <a:buNone/>
               <a:defRPr sz="1425" b="0">
                 <a:solidFill>
                   <a:srgbClr val="F4F9FC"/>
@@ -7357,6 +7440,7 @@
           </a:p>
           <a:p xmlns:a="http://schemas.openxmlformats.org/drawingml/2006/main">
             <a:pPr algn="ctr">
+              <a:buNone/>
               <a:defRPr sz="1425" b="0">
                 <a:solidFill>
                   <a:srgbClr val="F4F9FC"/>
@@ -7448,6 +7532,7 @@
           <a:lstStyle xmlns:a="http://schemas.openxmlformats.org/drawingml/2006/main"/>
           <a:p xmlns:a="http://schemas.openxmlformats.org/drawingml/2006/main">
             <a:pPr algn="ctr">
+              <a:buNone/>
               <a:defRPr sz="1050" b="1">
                 <a:solidFill>
                   <a:srgbClr val="8FA8BA"/>
@@ -7504,6 +7589,7 @@
           <a:lstStyle xmlns:a="http://schemas.openxmlformats.org/drawingml/2006/main"/>
           <a:p xmlns:a="http://schemas.openxmlformats.org/drawingml/2006/main">
             <a:pPr algn="l">
+              <a:buNone/>
               <a:defRPr sz="1200" b="1">
                 <a:solidFill>
                   <a:srgbClr val="FFBC5B"/>
@@ -7589,6 +7675,7 @@
           <a:lstStyle xmlns:a="http://schemas.openxmlformats.org/drawingml/2006/main"/>
           <a:p xmlns:a="http://schemas.openxmlformats.org/drawingml/2006/main">
             <a:pPr algn="l">
+              <a:buNone/>
               <a:defRPr sz="975" b="1">
                 <a:solidFill>
                   <a:srgbClr val="8FA8BA"/>
@@ -7645,6 +7732,7 @@
           <a:lstStyle xmlns:a="http://schemas.openxmlformats.org/drawingml/2006/main"/>
           <a:p xmlns:a="http://schemas.openxmlformats.org/drawingml/2006/main">
             <a:pPr algn="l">
+              <a:buNone/>
               <a:defRPr sz="975" b="1">
                 <a:solidFill>
                   <a:srgbClr val="39D8FF"/>
@@ -7732,6 +7820,7 @@
           <a:lstStyle xmlns:a="http://schemas.openxmlformats.org/drawingml/2006/main"/>
           <a:p xmlns:a="http://schemas.openxmlformats.org/drawingml/2006/main">
             <a:pPr algn="l">
+              <a:buNone/>
               <a:defRPr sz="750" b="0">
                 <a:solidFill>
                   <a:srgbClr val="8FA8BA"/>
@@ -7788,6 +7877,7 @@
           <a:lstStyle xmlns:a="http://schemas.openxmlformats.org/drawingml/2006/main"/>
           <a:p xmlns:a="http://schemas.openxmlformats.org/drawingml/2006/main">
             <a:pPr algn="r">
+              <a:buNone/>
               <a:defRPr sz="750" b="0">
                 <a:solidFill>
                   <a:srgbClr val="8FA8BA"/>
@@ -7844,6 +7934,7 @@
           <a:lstStyle xmlns:a="http://schemas.openxmlformats.org/drawingml/2006/main"/>
           <a:p xmlns:a="http://schemas.openxmlformats.org/drawingml/2006/main">
             <a:pPr algn="l">
+              <a:buNone/>
               <a:defRPr sz="3150" b="1">
                 <a:solidFill>
                   <a:srgbClr val="F4F9FC"/>
@@ -7867,6 +7958,7 @@
           </a:p>
           <a:p xmlns:a="http://schemas.openxmlformats.org/drawingml/2006/main">
             <a:pPr algn="l">
+              <a:buNone/>
               <a:defRPr sz="3150" b="1">
                 <a:solidFill>
                   <a:srgbClr val="F4F9FC"/>
@@ -8047,6 +8139,7 @@
           <a:lstStyle xmlns:a="http://schemas.openxmlformats.org/drawingml/2006/main"/>
           <a:p xmlns:a="http://schemas.openxmlformats.org/drawingml/2006/main">
             <a:pPr algn="l">
+              <a:buNone/>
               <a:defRPr sz="1050" b="1">
                 <a:solidFill>
                   <a:srgbClr val="39D8FF"/>
@@ -8103,6 +8196,7 @@
           <a:lstStyle xmlns:a="http://schemas.openxmlformats.org/drawingml/2006/main"/>
           <a:p xmlns:a="http://schemas.openxmlformats.org/drawingml/2006/main">
             <a:pPr algn="l">
+              <a:buNone/>
               <a:defRPr sz="1725" b="1">
                 <a:solidFill>
                   <a:srgbClr val="F4F9FC"/>
@@ -8121,11 +8215,12 @@
                 <a:ea typeface="Arial Unicode MS"/>
                 <a:cs typeface="Arial Unicode MS"/>
               </a:rPr>
-              <a:t>latency spike</a:t>
+              <a:t>1800ms latency</a:t>
             </a:r>
           </a:p>
           <a:p xmlns:a="http://schemas.openxmlformats.org/drawingml/2006/main">
             <a:pPr algn="l">
+              <a:buNone/>
               <a:defRPr sz="1725" b="1">
                 <a:solidFill>
                   <a:srgbClr val="F4F9FC"/>
@@ -8144,7 +8239,7 @@
                 <a:ea typeface="Arial Unicode MS"/>
                 <a:cs typeface="Arial Unicode MS"/>
               </a:rPr>
-              <a:t>regional failure</a:t>
+              <a:t>45% failure</a:t>
             </a:r>
           </a:p>
         </p:txBody>
@@ -8182,6 +8277,7 @@
           <a:lstStyle xmlns:a="http://schemas.openxmlformats.org/drawingml/2006/main"/>
           <a:p xmlns:a="http://schemas.openxmlformats.org/drawingml/2006/main">
             <a:pPr algn="l">
+              <a:buNone/>
               <a:defRPr sz="1050" b="1">
                 <a:solidFill>
                   <a:srgbClr val="FFBC5B"/>
@@ -8238,6 +8334,7 @@
           <a:lstStyle xmlns:a="http://schemas.openxmlformats.org/drawingml/2006/main"/>
           <a:p xmlns:a="http://schemas.openxmlformats.org/drawingml/2006/main">
             <a:pPr algn="l">
+              <a:buNone/>
               <a:defRPr sz="1725" b="1">
                 <a:solidFill>
                   <a:srgbClr val="F4F9FC"/>
@@ -8256,11 +8353,12 @@
                 <a:ea typeface="Arial Unicode MS"/>
                 <a:cs typeface="Arial Unicode MS"/>
               </a:rPr>
-              <a:t>cost pressure</a:t>
+              <a:t>12000ms latency</a:t>
             </a:r>
           </a:p>
           <a:p xmlns:a="http://schemas.openxmlformats.org/drawingml/2006/main">
             <a:pPr algn="l">
+              <a:buNone/>
               <a:defRPr sz="1725" b="1">
                 <a:solidFill>
                   <a:srgbClr val="F4F9FC"/>
@@ -8279,7 +8377,7 @@
                 <a:ea typeface="Arial Unicode MS"/>
                 <a:cs typeface="Arial Unicode MS"/>
               </a:rPr>
-              <a:t>healthy region</a:t>
+              <a:t>100% failure</a:t>
             </a:r>
           </a:p>
         </p:txBody>
@@ -8352,6 +8450,7 @@
           <a:lstStyle xmlns:a="http://schemas.openxmlformats.org/drawingml/2006/main"/>
           <a:p xmlns:a="http://schemas.openxmlformats.org/drawingml/2006/main">
             <a:pPr algn="ctr">
+              <a:buNone/>
               <a:defRPr sz="1275" b="1">
                 <a:solidFill>
                   <a:srgbClr val="39D8FF"/>
@@ -8408,6 +8507,7 @@
           <a:lstStyle xmlns:a="http://schemas.openxmlformats.org/drawingml/2006/main"/>
           <a:p xmlns:a="http://schemas.openxmlformats.org/drawingml/2006/main">
             <a:pPr algn="ctr">
+              <a:buNone/>
               <a:defRPr sz="1575" b="0">
                 <a:solidFill>
                   <a:srgbClr val="F4F9FC"/>
@@ -8431,6 +8531,7 @@
           </a:p>
           <a:p xmlns:a="http://schemas.openxmlformats.org/drawingml/2006/main">
             <a:pPr algn="ctr">
+              <a:buNone/>
               <a:defRPr sz="1575" b="0">
                 <a:solidFill>
                   <a:srgbClr val="F4F9FC"/>
@@ -8454,6 +8555,7 @@
           </a:p>
           <a:p xmlns:a="http://schemas.openxmlformats.org/drawingml/2006/main">
             <a:pPr algn="ctr">
+              <a:buNone/>
               <a:defRPr sz="1575" b="0">
                 <a:solidFill>
                   <a:srgbClr val="F4F9FC"/>
@@ -8477,6 +8579,7 @@
           </a:p>
           <a:p xmlns:a="http://schemas.openxmlformats.org/drawingml/2006/main">
             <a:pPr algn="ctr">
+              <a:buNone/>
               <a:defRPr sz="1575" b="0">
                 <a:solidFill>
                   <a:srgbClr val="F4F9FC"/>
@@ -8533,6 +8636,7 @@
           <a:lstStyle xmlns:a="http://schemas.openxmlformats.org/drawingml/2006/main"/>
           <a:p xmlns:a="http://schemas.openxmlformats.org/drawingml/2006/main">
             <a:pPr algn="ctr">
+              <a:buNone/>
               <a:defRPr sz="1800" b="1">
                 <a:solidFill>
                   <a:srgbClr val="46E6A6"/>
@@ -8551,7 +8655,7 @@
                 <a:ea typeface="Arial Unicode MS"/>
                 <a:cs typeface="Arial Unicode MS"/>
               </a:rPr>
-              <a:t>OFFER FAST</a:t>
+              <a:t>RPC STANDARD</a:t>
             </a:r>
           </a:p>
         </p:txBody>
@@ -8589,6 +8693,7 @@
           <a:lstStyle xmlns:a="http://schemas.openxmlformats.org/drawingml/2006/main"/>
           <a:p xmlns:a="http://schemas.openxmlformats.org/drawingml/2006/main">
             <a:pPr algn="ctr">
+              <a:buNone/>
               <a:defRPr sz="1800" b="1">
                 <a:solidFill>
                   <a:srgbClr val="FFBC5B"/>
@@ -8607,7 +8712,7 @@
                 <a:ea typeface="Arial Unicode MS"/>
                 <a:cs typeface="Arial Unicode MS"/>
               </a:rPr>
-              <a:t>OFFER ECONOMY</a:t>
+              <a:t>RPC EMERGENCY</a:t>
             </a:r>
           </a:p>
         </p:txBody>
@@ -8645,6 +8750,7 @@
           <a:lstStyle xmlns:a="http://schemas.openxmlformats.org/drawingml/2006/main"/>
           <a:p xmlns:a="http://schemas.openxmlformats.org/drawingml/2006/main">
             <a:pPr algn="ctr">
+              <a:buNone/>
               <a:defRPr sz="1275" b="1">
                 <a:solidFill>
                   <a:srgbClr val="8FA8BA"/>
@@ -8730,6 +8836,7 @@
           <a:lstStyle xmlns:a="http://schemas.openxmlformats.org/drawingml/2006/main"/>
           <a:p xmlns:a="http://schemas.openxmlformats.org/drawingml/2006/main">
             <a:pPr algn="l">
+              <a:buNone/>
               <a:defRPr sz="975" b="1">
                 <a:solidFill>
                   <a:srgbClr val="8FA8BA"/>
@@ -8786,6 +8893,7 @@
           <a:lstStyle xmlns:a="http://schemas.openxmlformats.org/drawingml/2006/main"/>
           <a:p xmlns:a="http://schemas.openxmlformats.org/drawingml/2006/main">
             <a:pPr algn="l">
+              <a:buNone/>
               <a:defRPr sz="975" b="1">
                 <a:solidFill>
                   <a:srgbClr val="39D8FF"/>
@@ -8873,6 +8981,7 @@
           <a:lstStyle xmlns:a="http://schemas.openxmlformats.org/drawingml/2006/main"/>
           <a:p xmlns:a="http://schemas.openxmlformats.org/drawingml/2006/main">
             <a:pPr algn="l">
+              <a:buNone/>
               <a:defRPr sz="750" b="0">
                 <a:solidFill>
                   <a:srgbClr val="8FA8BA"/>
@@ -8929,6 +9038,7 @@
           <a:lstStyle xmlns:a="http://schemas.openxmlformats.org/drawingml/2006/main"/>
           <a:p xmlns:a="http://schemas.openxmlformats.org/drawingml/2006/main">
             <a:pPr algn="r">
+              <a:buNone/>
               <a:defRPr sz="750" b="0">
                 <a:solidFill>
                   <a:srgbClr val="8FA8BA"/>
@@ -8985,6 +9095,7 @@
           <a:lstStyle xmlns:a="http://schemas.openxmlformats.org/drawingml/2006/main"/>
           <a:p xmlns:a="http://schemas.openxmlformats.org/drawingml/2006/main">
             <a:pPr algn="l">
+              <a:buNone/>
               <a:defRPr sz="3150" b="1">
                 <a:solidFill>
                   <a:srgbClr val="F4F9FC"/>
@@ -9008,6 +9119,7 @@
           </a:p>
           <a:p xmlns:a="http://schemas.openxmlformats.org/drawingml/2006/main">
             <a:pPr algn="l">
+              <a:buNone/>
               <a:defRPr sz="3150" b="1">
                 <a:solidFill>
                   <a:srgbClr val="F4F9FC"/>
@@ -9128,6 +9240,7 @@
           <a:lstStyle xmlns:a="http://schemas.openxmlformats.org/drawingml/2006/main"/>
           <a:p xmlns:a="http://schemas.openxmlformats.org/drawingml/2006/main">
             <a:pPr algn="r">
+              <a:buNone/>
               <a:defRPr sz="1125" b="1">
                 <a:solidFill>
                   <a:srgbClr val="39D8FF"/>
@@ -9184,6 +9297,7 @@
           <a:lstStyle xmlns:a="http://schemas.openxmlformats.org/drawingml/2006/main"/>
           <a:p xmlns:a="http://schemas.openxmlformats.org/drawingml/2006/main">
             <a:pPr algn="r">
+              <a:buNone/>
               <a:defRPr sz="1350" b="1">
                 <a:solidFill>
                   <a:srgbClr val="F4F9FC"/>
@@ -9202,7 +9316,7 @@
                 <a:ea typeface="Arial Unicode MS"/>
                 <a:cs typeface="Arial Unicode MS"/>
               </a:rPr>
-              <a:t>modelVersion + redacted input/output hashes</a:t>
+              <a:t>Gemini 2.5 Flash · strict 2-offer choice</a:t>
             </a:r>
           </a:p>
         </p:txBody>
@@ -9273,6 +9387,7 @@
           <a:lstStyle xmlns:a="http://schemas.openxmlformats.org/drawingml/2006/main"/>
           <a:p xmlns:a="http://schemas.openxmlformats.org/drawingml/2006/main">
             <a:pPr algn="l">
+              <a:buNone/>
               <a:defRPr sz="1125" b="1">
                 <a:solidFill>
                   <a:srgbClr val="39D8FF"/>
@@ -9329,6 +9444,7 @@
           <a:lstStyle xmlns:a="http://schemas.openxmlformats.org/drawingml/2006/main"/>
           <a:p xmlns:a="http://schemas.openxmlformats.org/drawingml/2006/main">
             <a:pPr algn="l">
+              <a:buNone/>
               <a:defRPr sz="1350" b="1">
                 <a:solidFill>
                   <a:srgbClr val="F4F9FC"/>
@@ -9347,7 +9463,7 @@
                 <a:ea typeface="Arial Unicode MS"/>
                 <a:cs typeface="Arial Unicode MS"/>
               </a:rPr>
-              <a:t>Agent Card + 2 signed offers</a:t>
+              <a:t>Agent Card · 2 signed offers · A2A</a:t>
             </a:r>
           </a:p>
         </p:txBody>
@@ -9418,6 +9534,7 @@
           <a:lstStyle xmlns:a="http://schemas.openxmlformats.org/drawingml/2006/main"/>
           <a:p xmlns:a="http://schemas.openxmlformats.org/drawingml/2006/main">
             <a:pPr algn="r">
+              <a:buNone/>
               <a:defRPr sz="1125" b="1">
                 <a:solidFill>
                   <a:srgbClr val="FFBC5B"/>
@@ -9474,6 +9591,7 @@
           <a:lstStyle xmlns:a="http://schemas.openxmlformats.org/drawingml/2006/main"/>
           <a:p xmlns:a="http://schemas.openxmlformats.org/drawingml/2006/main">
             <a:pPr algn="r">
+              <a:buNone/>
               <a:defRPr sz="1350" b="1">
                 <a:solidFill>
                   <a:srgbClr val="F4F9FC"/>
@@ -9492,7 +9610,7 @@
                 <a:ea typeface="Arial Unicode MS"/>
                 <a:cs typeface="Arial Unicode MS"/>
               </a:rPr>
-              <a:t>ordered rules + budget before/after</a:t>
+              <a:t>0.015 USDC · budget 50000 → 35000</a:t>
             </a:r>
           </a:p>
         </p:txBody>
@@ -9563,6 +9681,7 @@
           <a:lstStyle xmlns:a="http://schemas.openxmlformats.org/drawingml/2006/main"/>
           <a:p xmlns:a="http://schemas.openxmlformats.org/drawingml/2006/main">
             <a:pPr algn="l">
+              <a:buNone/>
               <a:defRPr sz="1125" b="1">
                 <a:solidFill>
                   <a:srgbClr val="39D8FF"/>
@@ -9619,6 +9738,7 @@
           <a:lstStyle xmlns:a="http://schemas.openxmlformats.org/drawingml/2006/main"/>
           <a:p xmlns:a="http://schemas.openxmlformats.org/drawingml/2006/main">
             <a:pPr algn="l">
+              <a:buNone/>
               <a:defRPr sz="1350" b="1">
                 <a:solidFill>
                   <a:srgbClr val="F4F9FC"/>
@@ -9637,7 +9757,7 @@
                 <a:ea typeface="Arial Unicode MS"/>
                 <a:cs typeface="Arial Unicode MS"/>
               </a:rPr>
-              <a:t>402 / signed retry / 200 raw headers</a:t>
+              <a:t>402 → signed retry → settled 200</a:t>
             </a:r>
           </a:p>
         </p:txBody>
@@ -9708,6 +9828,7 @@
           <a:lstStyle xmlns:a="http://schemas.openxmlformats.org/drawingml/2006/main"/>
           <a:p xmlns:a="http://schemas.openxmlformats.org/drawingml/2006/main">
             <a:pPr algn="r">
+              <a:buNone/>
               <a:defRPr sz="1125" b="1">
                 <a:solidFill>
                   <a:srgbClr val="46E6A6"/>
@@ -9764,6 +9885,7 @@
           <a:lstStyle xmlns:a="http://schemas.openxmlformats.org/drawingml/2006/main"/>
           <a:p xmlns:a="http://schemas.openxmlformats.org/drawingml/2006/main">
             <a:pPr algn="r">
+              <a:buNone/>
               <a:defRPr sz="1350" b="1">
                 <a:solidFill>
                   <a:srgbClr val="F4F9FC"/>
@@ -9782,7 +9904,7 @@
                 <a:ea typeface="Arial Unicode MS"/>
                 <a:cs typeface="Arial Unicode MS"/>
               </a:rPr>
-              <a:t>payer/payee + exact token deltas + Explorer</a:t>
+              <a:t>payer -15000 · payee +15000 USDC</a:t>
             </a:r>
           </a:p>
         </p:txBody>
@@ -9853,6 +9975,7 @@
           <a:lstStyle xmlns:a="http://schemas.openxmlformats.org/drawingml/2006/main"/>
           <a:p xmlns:a="http://schemas.openxmlformats.org/drawingml/2006/main">
             <a:pPr algn="l">
+              <a:buNone/>
               <a:defRPr sz="1125" b="1">
                 <a:solidFill>
                   <a:srgbClr val="46E6A6"/>
@@ -9909,6 +10032,7 @@
           <a:lstStyle xmlns:a="http://schemas.openxmlformats.org/drawingml/2006/main"/>
           <a:p xmlns:a="http://schemas.openxmlformats.org/drawingml/2006/main">
             <a:pPr algn="l">
+              <a:buNone/>
               <a:defRPr sz="1350" b="1">
                 <a:solidFill>
                   <a:srgbClr val="F4F9FC"/>
@@ -9927,7 +10051,7 @@
                 <a:ea typeface="Arial Unicode MS"/>
                 <a:cs typeface="Arial Unicode MS"/>
               </a:rPr>
-              <a:t>vendor receipt + distinct healthy outcome</a:t>
+              <a:t>4P7Y…KtmZ · slot 480903755 · healthy 9.340s</a:t>
             </a:r>
           </a:p>
         </p:txBody>
@@ -9994,6 +10118,7 @@
           <a:lstStyle xmlns:a="http://schemas.openxmlformats.org/drawingml/2006/main"/>
           <a:p xmlns:a="http://schemas.openxmlformats.org/drawingml/2006/main">
             <a:pPr algn="l">
+              <a:buNone/>
               <a:defRPr sz="975" b="1">
                 <a:solidFill>
                   <a:srgbClr val="8FA8BA"/>
@@ -10050,6 +10175,7 @@
           <a:lstStyle xmlns:a="http://schemas.openxmlformats.org/drawingml/2006/main"/>
           <a:p xmlns:a="http://schemas.openxmlformats.org/drawingml/2006/main">
             <a:pPr algn="l">
+              <a:buNone/>
               <a:defRPr sz="975" b="1">
                 <a:solidFill>
                   <a:srgbClr val="39D8FF"/>
@@ -10137,6 +10263,7 @@
           <a:lstStyle xmlns:a="http://schemas.openxmlformats.org/drawingml/2006/main"/>
           <a:p xmlns:a="http://schemas.openxmlformats.org/drawingml/2006/main">
             <a:pPr algn="l">
+              <a:buNone/>
               <a:defRPr sz="750" b="0">
                 <a:solidFill>
                   <a:srgbClr val="8FA8BA"/>
@@ -10193,6 +10320,7 @@
           <a:lstStyle xmlns:a="http://schemas.openxmlformats.org/drawingml/2006/main"/>
           <a:p xmlns:a="http://schemas.openxmlformats.org/drawingml/2006/main">
             <a:pPr algn="r">
+              <a:buNone/>
               <a:defRPr sz="750" b="0">
                 <a:solidFill>
                   <a:srgbClr val="8FA8BA"/>
@@ -10249,6 +10377,7 @@
           <a:lstStyle xmlns:a="http://schemas.openxmlformats.org/drawingml/2006/main"/>
           <a:p xmlns:a="http://schemas.openxmlformats.org/drawingml/2006/main">
             <a:pPr algn="l">
+              <a:buNone/>
               <a:defRPr sz="3225" b="1">
                 <a:solidFill>
                   <a:srgbClr val="F4F9FC"/>
@@ -10267,7 +10396,7 @@
                 <a:ea typeface="Arial Unicode MS"/>
                 <a:cs typeface="Arial Unicode MS"/>
               </a:rPr>
-              <a:t>거절은 signer보다 먼저 일어납니다.</a:t>
+              <a:t>두 거절 모두 signer 전에 끝났습니다.</a:t>
             </a:r>
           </a:p>
         </p:txBody>
@@ -10305,6 +10434,7 @@
           <a:lstStyle xmlns:a="http://schemas.openxmlformats.org/drawingml/2006/main"/>
           <a:p xmlns:a="http://schemas.openxmlformats.org/drawingml/2006/main">
             <a:pPr algn="l">
+              <a:buNone/>
               <a:defRPr sz="1875" b="1">
                 <a:solidFill>
                   <a:srgbClr val="8FA8BA"/>
@@ -10361,6 +10491,7 @@
           <a:lstStyle xmlns:a="http://schemas.openxmlformats.org/drawingml/2006/main"/>
           <a:p xmlns:a="http://schemas.openxmlformats.org/drawingml/2006/main">
             <a:pPr algn="l">
+              <a:buNone/>
               <a:defRPr sz="5850" b="1">
                 <a:solidFill>
                   <a:srgbClr val="FF5C75"/>
@@ -10417,6 +10548,7 @@
           <a:lstStyle xmlns:a="http://schemas.openxmlformats.org/drawingml/2006/main"/>
           <a:p xmlns:a="http://schemas.openxmlformats.org/drawingml/2006/main">
             <a:pPr algn="l">
+              <a:buNone/>
               <a:defRPr sz="1575" b="1">
                 <a:solidFill>
                   <a:srgbClr val="F4F9FC"/>
@@ -10504,6 +10636,7 @@
           <a:lstStyle xmlns:a="http://schemas.openxmlformats.org/drawingml/2006/main"/>
           <a:p xmlns:a="http://schemas.openxmlformats.org/drawingml/2006/main">
             <a:pPr algn="l">
+              <a:buNone/>
               <a:defRPr sz="1050" b="1">
                 <a:solidFill>
                   <a:srgbClr val="FF5C75"/>
@@ -10522,7 +10655,7 @@
                 <a:ea typeface="Arial Unicode MS"/>
                 <a:cs typeface="Arial Unicode MS"/>
               </a:rPr>
-              <a:t>OVER CAP</a:t>
+              <a:t>amount.per_transaction_limit</a:t>
             </a:r>
           </a:p>
         </p:txBody>
@@ -10560,6 +10693,7 @@
           <a:lstStyle xmlns:a="http://schemas.openxmlformats.org/drawingml/2006/main"/>
           <a:p xmlns:a="http://schemas.openxmlformats.org/drawingml/2006/main">
             <a:pPr algn="l">
+              <a:buNone/>
               <a:defRPr sz="1425" b="1">
                 <a:solidFill>
                   <a:srgbClr val="F4F9FC"/>
@@ -10578,7 +10712,7 @@
                 <a:ea typeface="Arial Unicode MS"/>
                 <a:cs typeface="Arial Unicode MS"/>
               </a:rPr>
-              <a:t>deny before reserve / signer</a:t>
+              <a:t>25000 &gt; 20000 · false / null</a:t>
             </a:r>
           </a:p>
         </p:txBody>
@@ -10647,6 +10781,7 @@
           <a:lstStyle xmlns:a="http://schemas.openxmlformats.org/drawingml/2006/main"/>
           <a:p xmlns:a="http://schemas.openxmlformats.org/drawingml/2006/main">
             <a:pPr algn="l">
+              <a:buNone/>
               <a:defRPr sz="1050" b="1">
                 <a:solidFill>
                   <a:srgbClr val="FF5C75"/>
@@ -10665,7 +10800,7 @@
                 <a:ea typeface="Arial Unicode MS"/>
                 <a:cs typeface="Arial Unicode MS"/>
               </a:rPr>
-              <a:t>NONCE REPLAY</a:t>
+              <a:t>identifier.nonce_fresh</a:t>
             </a:r>
           </a:p>
         </p:txBody>
@@ -10703,6 +10838,7 @@
           <a:lstStyle xmlns:a="http://schemas.openxmlformats.org/drawingml/2006/main"/>
           <a:p xmlns:a="http://schemas.openxmlformats.org/drawingml/2006/main">
             <a:pPr algn="l">
+              <a:buNone/>
               <a:defRPr sz="1425" b="1">
                 <a:solidFill>
                   <a:srgbClr val="F4F9FC"/>
@@ -10721,7 +10857,7 @@
                 <a:ea typeface="Arial Unicode MS"/>
                 <a:cs typeface="Arial Unicode MS"/>
               </a:rPr>
-              <a:t>same ID bound to first fingerprint</a:t>
+              <a:t>same nonce · fresh payment + idem IDs</a:t>
             </a:r>
           </a:p>
         </p:txBody>
@@ -10790,6 +10926,7 @@
           <a:lstStyle xmlns:a="http://schemas.openxmlformats.org/drawingml/2006/main"/>
           <a:p xmlns:a="http://schemas.openxmlformats.org/drawingml/2006/main">
             <a:pPr algn="l">
+              <a:buNone/>
               <a:defRPr sz="1050" b="1">
                 <a:solidFill>
                   <a:srgbClr val="FFBC5B"/>
@@ -10846,6 +10983,7 @@
           <a:lstStyle xmlns:a="http://schemas.openxmlformats.org/drawingml/2006/main"/>
           <a:p xmlns:a="http://schemas.openxmlformats.org/drawingml/2006/main">
             <a:pPr algn="l">
+              <a:buNone/>
               <a:defRPr sz="1425" b="1">
                 <a:solidFill>
                   <a:srgbClr val="F4F9FC"/>
@@ -10933,6 +11071,7 @@
           <a:lstStyle xmlns:a="http://schemas.openxmlformats.org/drawingml/2006/main"/>
           <a:p xmlns:a="http://schemas.openxmlformats.org/drawingml/2006/main">
             <a:pPr algn="l">
+              <a:buNone/>
               <a:defRPr sz="1050" b="1">
                 <a:solidFill>
                   <a:srgbClr val="FFBC5B"/>
@@ -10989,6 +11128,7 @@
           <a:lstStyle xmlns:a="http://schemas.openxmlformats.org/drawingml/2006/main"/>
           <a:p xmlns:a="http://schemas.openxmlformats.org/drawingml/2006/main">
             <a:pPr algn="l">
+              <a:buNone/>
               <a:defRPr sz="1425" b="1">
                 <a:solidFill>
                   <a:srgbClr val="F4F9FC"/>
@@ -11076,6 +11216,7 @@
           <a:lstStyle xmlns:a="http://schemas.openxmlformats.org/drawingml/2006/main"/>
           <a:p xmlns:a="http://schemas.openxmlformats.org/drawingml/2006/main">
             <a:pPr algn="l">
+              <a:buNone/>
               <a:defRPr sz="1050" b="1">
                 <a:solidFill>
                   <a:srgbClr val="FFBC5B"/>
@@ -11132,6 +11273,7 @@
           <a:lstStyle xmlns:a="http://schemas.openxmlformats.org/drawingml/2006/main"/>
           <a:p xmlns:a="http://schemas.openxmlformats.org/drawingml/2006/main">
             <a:pPr algn="l">
+              <a:buNone/>
               <a:defRPr sz="1425" b="1">
                 <a:solidFill>
                   <a:srgbClr val="F4F9FC"/>
@@ -11219,6 +11361,7 @@
           <a:lstStyle xmlns:a="http://schemas.openxmlformats.org/drawingml/2006/main"/>
           <a:p xmlns:a="http://schemas.openxmlformats.org/drawingml/2006/main">
             <a:pPr algn="l">
+              <a:buNone/>
               <a:defRPr sz="1200" b="1">
                 <a:solidFill>
                   <a:srgbClr val="FFBC5B"/>
@@ -11304,6 +11447,7 @@
           <a:lstStyle xmlns:a="http://schemas.openxmlformats.org/drawingml/2006/main"/>
           <a:p xmlns:a="http://schemas.openxmlformats.org/drawingml/2006/main">
             <a:pPr algn="l">
+              <a:buNone/>
               <a:defRPr sz="1350" b="1">
                 <a:solidFill>
                   <a:srgbClr val="39D8FF"/>
@@ -11360,6 +11504,7 @@
           <a:lstStyle xmlns:a="http://schemas.openxmlformats.org/drawingml/2006/main"/>
           <a:p xmlns:a="http://schemas.openxmlformats.org/drawingml/2006/main">
             <a:pPr algn="l">
+              <a:buNone/>
               <a:defRPr sz="2700" b="1">
                 <a:solidFill>
                   <a:srgbClr val="F4F9FC"/>
@@ -11416,6 +11561,7 @@
           <a:lstStyle xmlns:a="http://schemas.openxmlformats.org/drawingml/2006/main"/>
           <a:p xmlns:a="http://schemas.openxmlformats.org/drawingml/2006/main">
             <a:pPr algn="ctr">
+              <a:buNone/>
               <a:defRPr sz="2700" b="1">
                 <a:solidFill>
                   <a:srgbClr val="274055"/>
@@ -11472,6 +11618,7 @@
           <a:lstStyle xmlns:a="http://schemas.openxmlformats.org/drawingml/2006/main"/>
           <a:p xmlns:a="http://schemas.openxmlformats.org/drawingml/2006/main">
             <a:pPr algn="l">
+              <a:buNone/>
               <a:defRPr sz="2700" b="1">
                 <a:solidFill>
                   <a:srgbClr val="39D8FF"/>
@@ -11528,6 +11675,7 @@
           <a:lstStyle xmlns:a="http://schemas.openxmlformats.org/drawingml/2006/main"/>
           <a:p xmlns:a="http://schemas.openxmlformats.org/drawingml/2006/main">
             <a:pPr algn="ctr">
+              <a:buNone/>
               <a:defRPr sz="2700" b="1">
                 <a:solidFill>
                   <a:srgbClr val="274055"/>
@@ -11584,6 +11732,7 @@
           <a:lstStyle xmlns:a="http://schemas.openxmlformats.org/drawingml/2006/main"/>
           <a:p xmlns:a="http://schemas.openxmlformats.org/drawingml/2006/main">
             <a:pPr algn="l">
+              <a:buNone/>
               <a:defRPr sz="2700" b="1">
                 <a:solidFill>
                   <a:srgbClr val="FFBC5B"/>
@@ -11640,6 +11789,7 @@
           <a:lstStyle xmlns:a="http://schemas.openxmlformats.org/drawingml/2006/main"/>
           <a:p xmlns:a="http://schemas.openxmlformats.org/drawingml/2006/main">
             <a:pPr algn="ctr">
+              <a:buNone/>
               <a:defRPr sz="2700" b="1">
                 <a:solidFill>
                   <a:srgbClr val="274055"/>
@@ -11696,6 +11846,7 @@
           <a:lstStyle xmlns:a="http://schemas.openxmlformats.org/drawingml/2006/main"/>
           <a:p xmlns:a="http://schemas.openxmlformats.org/drawingml/2006/main">
             <a:pPr algn="l">
+              <a:buNone/>
               <a:defRPr sz="2700" b="1">
                 <a:solidFill>
                   <a:srgbClr val="46E6A6"/>
@@ -11752,6 +11903,7 @@
           <a:lstStyle xmlns:a="http://schemas.openxmlformats.org/drawingml/2006/main"/>
           <a:p xmlns:a="http://schemas.openxmlformats.org/drawingml/2006/main">
             <a:pPr algn="ctr">
+              <a:buNone/>
               <a:defRPr sz="2700" b="1">
                 <a:solidFill>
                   <a:srgbClr val="274055"/>
@@ -11808,6 +11960,7 @@
           <a:lstStyle xmlns:a="http://schemas.openxmlformats.org/drawingml/2006/main"/>
           <a:p xmlns:a="http://schemas.openxmlformats.org/drawingml/2006/main">
             <a:pPr algn="l">
+              <a:buNone/>
               <a:defRPr sz="2700" b="1">
                 <a:solidFill>
                   <a:srgbClr val="F4F9FC"/>
@@ -11895,6 +12048,7 @@
           <a:lstStyle xmlns:a="http://schemas.openxmlformats.org/drawingml/2006/main"/>
           <a:p xmlns:a="http://schemas.openxmlformats.org/drawingml/2006/main">
             <a:pPr algn="ctr">
+              <a:buNone/>
               <a:defRPr sz="2850" b="1">
                 <a:solidFill>
                   <a:srgbClr val="F4F9FC"/>
@@ -11918,6 +12072,7 @@
           </a:p>
           <a:p xmlns:a="http://schemas.openxmlformats.org/drawingml/2006/main">
             <a:pPr algn="ctr">
+              <a:buNone/>
               <a:defRPr sz="2850" b="1">
                 <a:solidFill>
                   <a:srgbClr val="F4F9FC"/>
@@ -11974,6 +12129,7 @@
           <a:lstStyle xmlns:a="http://schemas.openxmlformats.org/drawingml/2006/main"/>
           <a:p xmlns:a="http://schemas.openxmlformats.org/drawingml/2006/main">
             <a:pPr algn="ctr">
+              <a:buNone/>
               <a:defRPr sz="1800" b="1">
                 <a:solidFill>
                   <a:srgbClr val="46E6A6"/>

</xml_diff>

<commit_message>
polish final evidence replay release
</commit_message>
<xml_diff>
--- a/submission/Uptime402_Deck.pptx
+++ b/submission/Uptime402_Deck.pptx
@@ -2,21 +2,21 @@
 <file path=ppt/presentation.xml><?xml version="1.0" encoding="utf-8"?>
 <p:presentation xmlns:p="http://schemas.openxmlformats.org/presentationml/2006/main">
   <p:sldMasterIdLst>
-    <p:sldMasterId xmlns:r="http://schemas.openxmlformats.org/officeDocument/2006/relationships" id="2147483648" r:id="R6c1f3e516feb4dfc"/>
+    <p:sldMasterId xmlns:r="http://schemas.openxmlformats.org/officeDocument/2006/relationships" id="2147483648" r:id="R2b16e96bc2804137"/>
   </p:sldMasterIdLst>
   <p:notesMasterIdLst>
-    <p:notesMasterId xmlns:r="http://schemas.openxmlformats.org/officeDocument/2006/relationships" r:id="R71434858e4534035"/>
+    <p:notesMasterId xmlns:r="http://schemas.openxmlformats.org/officeDocument/2006/relationships" r:id="R02f0fff4a8b14597"/>
   </p:notesMasterIdLst>
   <p:sldIdLst>
-    <p:sldId xmlns:r="http://schemas.openxmlformats.org/officeDocument/2006/relationships" id="256" r:id="R77f62fdbbc1a46f2"/>
-    <p:sldId xmlns:r="http://schemas.openxmlformats.org/officeDocument/2006/relationships" id="257" r:id="R7423c4e27f6e4df3"/>
-    <p:sldId xmlns:r="http://schemas.openxmlformats.org/officeDocument/2006/relationships" id="258" r:id="Re0a73092d0a8454f"/>
-    <p:sldId xmlns:r="http://schemas.openxmlformats.org/officeDocument/2006/relationships" id="259" r:id="Rd5d01d7e00bd43bb"/>
-    <p:sldId xmlns:r="http://schemas.openxmlformats.org/officeDocument/2006/relationships" id="260" r:id="R1c5b222f535e46d6"/>
-    <p:sldId xmlns:r="http://schemas.openxmlformats.org/officeDocument/2006/relationships" id="261" r:id="R4ca58d41dc1e4300"/>
-    <p:sldId xmlns:r="http://schemas.openxmlformats.org/officeDocument/2006/relationships" id="262" r:id="R894df5a5044c45b6"/>
-    <p:sldId xmlns:r="http://schemas.openxmlformats.org/officeDocument/2006/relationships" id="263" r:id="R837fcd857eb94985"/>
-    <p:sldId xmlns:r="http://schemas.openxmlformats.org/officeDocument/2006/relationships" id="264" r:id="R8d5ae358944e47a2"/>
+    <p:sldId xmlns:r="http://schemas.openxmlformats.org/officeDocument/2006/relationships" id="256" r:id="Rbb47799a44784ba1"/>
+    <p:sldId xmlns:r="http://schemas.openxmlformats.org/officeDocument/2006/relationships" id="257" r:id="Rb93c6f38bba44b20"/>
+    <p:sldId xmlns:r="http://schemas.openxmlformats.org/officeDocument/2006/relationships" id="258" r:id="Rec92858dd1cb4eb4"/>
+    <p:sldId xmlns:r="http://schemas.openxmlformats.org/officeDocument/2006/relationships" id="259" r:id="Ree55a42a66784661"/>
+    <p:sldId xmlns:r="http://schemas.openxmlformats.org/officeDocument/2006/relationships" id="260" r:id="R8b4a2744fc5c42d5"/>
+    <p:sldId xmlns:r="http://schemas.openxmlformats.org/officeDocument/2006/relationships" id="261" r:id="R06a125cdcd184920"/>
+    <p:sldId xmlns:r="http://schemas.openxmlformats.org/officeDocument/2006/relationships" id="262" r:id="R25f1bba1d8494b5a"/>
+    <p:sldId xmlns:r="http://schemas.openxmlformats.org/officeDocument/2006/relationships" id="263" r:id="R3c766f5895a444c4"/>
+    <p:sldId xmlns:r="http://schemas.openxmlformats.org/officeDocument/2006/relationships" id="264" r:id="Rf62aa2a06be74f5c"/>
   </p:sldIdLst>
   <p:sldSz cx="12192000" cy="6858000"/>
   <p:notesSz cx="6858000" cy="9144000"/>
@@ -963,6 +963,13 @@
               <a:t>- https://docs.x402.org/extensions/offer-receipt</a:t>
             </a:r>
           </a:p>
+          <a:p xmlns:a="http://schemas.openxmlformats.org/drawingml/2006/main">
+            <a:r>
+              <a:t>
+- Repository: artifacts/payment-evidence.json (sha256:0a7bfbb00b07ad29d0a74a4d28e5f8d443c94e6bd5034eeb6b7463463b332df4)
+- Repository: artifacts/verification-report.json (sha256:b147e7cfe2c71fee903f4052ca342d8266343694e48843ae017c8e55ae42cd3e)</a:t>
+            </a:r>
+          </a:p>
         </p:txBody>
       </p:sp>
       <p:sp>
@@ -1131,6 +1138,13 @@
           <a:p xmlns:a="http://schemas.openxmlformats.org/drawingml/2006/main">
             <a:r>
               <a:t>- Repository: docs/DEMO_SCRIPT.md</a:t>
+            </a:r>
+          </a:p>
+          <a:p xmlns:a="http://schemas.openxmlformats.org/drawingml/2006/main">
+            <a:r>
+              <a:t>
+- Repository: artifacts/payment-evidence.json (sha256:0a7bfbb00b07ad29d0a74a4d28e5f8d443c94e6bd5034eeb6b7463463b332df4)
+- Repository: artifacts/verification-report.json (sha256:b147e7cfe2c71fee903f4052ca342d8266343694e48843ae017c8e55ae42cd3e)</a:t>
             </a:r>
           </a:p>
         </p:txBody>
@@ -1198,7 +1212,7 @@
   </p:cSld>
   <p:clrMap bg1="lt1" tx1="dk1" bg2="lt2" tx2="dk2" accent1="accent1" accent2="accent2" accent3="accent3" accent4="accent4" accent5="accent5" accent6="accent6" hlink="hlink" folHlink="folHlink"/>
   <p:sldLayoutIdLst>
-    <p:sldLayoutId xmlns:r="http://schemas.openxmlformats.org/officeDocument/2006/relationships" id="2147483649" r:id="R572e26e82af04e0c"/>
+    <p:sldLayoutId xmlns:r="http://schemas.openxmlformats.org/officeDocument/2006/relationships" id="2147483649" r:id="R4250e296756c46aa"/>
   </p:sldLayoutIdLst>
   <p:txStyles>
     <p:titleStyle>
@@ -9057,7 +9071,7 @@
                 <a:ea typeface="Arial Unicode MS"/>
                 <a:cs typeface="Arial Unicode MS"/>
               </a:rPr>
-              <a:t>EVIDENCE-FIRST P0</a:t>
+              <a:t>EV 0a7bfbb0 · VR b147e7cf</a:t>
             </a:r>
           </a:p>
         </p:txBody>
@@ -9610,7 +9624,7 @@
                 <a:ea typeface="Arial Unicode MS"/>
                 <a:cs typeface="Arial Unicode MS"/>
               </a:rPr>
-              <a:t>0.015 USDC · budget 50000 → 35000</a:t>
+              <a:t>0.015 USDC · budget 0.050 → 0.035</a:t>
             </a:r>
           </a:p>
         </p:txBody>
@@ -11466,7 +11480,7 @@
                 <a:ea typeface="Arial Unicode MS"/>
                 <a:cs typeface="Arial Unicode MS"/>
               </a:rPr>
-              <a:t>UPTIME402</a:t>
+              <a:t>finalist-demo-5</a:t>
             </a:r>
           </a:p>
         </p:txBody>
@@ -12091,7 +12105,7 @@
                 <a:ea typeface="Arial Unicode MS"/>
                 <a:cs typeface="Arial Unicode MS"/>
               </a:rPr>
-              <a:t>One verifiable recovery timeline.</a:t>
+              <a:t>READ-ONLY REPLAY · NO NEW PAYMENT</a:t>
             </a:r>
           </a:p>
         </p:txBody>
@@ -12148,7 +12162,7 @@
                 <a:ea typeface="Arial Unicode MS"/>
                 <a:cs typeface="Arial Unicode MS"/>
               </a:rPr>
-              <a:t>An outage does not wait for procurement.</a:t>
+              <a:t>0.015 USDC · 9.340s · budget 0.050→0.035 · 4P7Y…KtmZ</a:t>
             </a:r>
           </a:p>
         </p:txBody>

</xml_diff>

<commit_message>
feat: publish Uptime402 portfolio release
</commit_message>
<xml_diff>
--- a/submission/Uptime402_Deck.pptx
+++ b/submission/Uptime402_Deck.pptx
@@ -2,21 +2,21 @@
 <file path=ppt/presentation.xml><?xml version="1.0" encoding="utf-8"?>
 <p:presentation xmlns:p="http://schemas.openxmlformats.org/presentationml/2006/main">
   <p:sldMasterIdLst>
-    <p:sldMasterId xmlns:r="http://schemas.openxmlformats.org/officeDocument/2006/relationships" id="2147483648" r:id="R2b16e96bc2804137"/>
+    <p:sldMasterId xmlns:r="http://schemas.openxmlformats.org/officeDocument/2006/relationships" id="2147483648" r:id="Re84efa9a2968464f"/>
   </p:sldMasterIdLst>
   <p:notesMasterIdLst>
-    <p:notesMasterId xmlns:r="http://schemas.openxmlformats.org/officeDocument/2006/relationships" r:id="R02f0fff4a8b14597"/>
+    <p:notesMasterId xmlns:r="http://schemas.openxmlformats.org/officeDocument/2006/relationships" r:id="R0db44a77bcdf4190"/>
   </p:notesMasterIdLst>
   <p:sldIdLst>
-    <p:sldId xmlns:r="http://schemas.openxmlformats.org/officeDocument/2006/relationships" id="256" r:id="Rbb47799a44784ba1"/>
-    <p:sldId xmlns:r="http://schemas.openxmlformats.org/officeDocument/2006/relationships" id="257" r:id="Rb93c6f38bba44b20"/>
-    <p:sldId xmlns:r="http://schemas.openxmlformats.org/officeDocument/2006/relationships" id="258" r:id="Rec92858dd1cb4eb4"/>
-    <p:sldId xmlns:r="http://schemas.openxmlformats.org/officeDocument/2006/relationships" id="259" r:id="Ree55a42a66784661"/>
-    <p:sldId xmlns:r="http://schemas.openxmlformats.org/officeDocument/2006/relationships" id="260" r:id="R8b4a2744fc5c42d5"/>
-    <p:sldId xmlns:r="http://schemas.openxmlformats.org/officeDocument/2006/relationships" id="261" r:id="R06a125cdcd184920"/>
-    <p:sldId xmlns:r="http://schemas.openxmlformats.org/officeDocument/2006/relationships" id="262" r:id="R25f1bba1d8494b5a"/>
-    <p:sldId xmlns:r="http://schemas.openxmlformats.org/officeDocument/2006/relationships" id="263" r:id="R3c766f5895a444c4"/>
-    <p:sldId xmlns:r="http://schemas.openxmlformats.org/officeDocument/2006/relationships" id="264" r:id="Rf62aa2a06be74f5c"/>
+    <p:sldId xmlns:r="http://schemas.openxmlformats.org/officeDocument/2006/relationships" id="256" r:id="Rb42fc58201774d77"/>
+    <p:sldId xmlns:r="http://schemas.openxmlformats.org/officeDocument/2006/relationships" id="257" r:id="Re4a491b081d54e3f"/>
+    <p:sldId xmlns:r="http://schemas.openxmlformats.org/officeDocument/2006/relationships" id="258" r:id="R6b43cda474044634"/>
+    <p:sldId xmlns:r="http://schemas.openxmlformats.org/officeDocument/2006/relationships" id="259" r:id="R8a34064391f344cc"/>
+    <p:sldId xmlns:r="http://schemas.openxmlformats.org/officeDocument/2006/relationships" id="260" r:id="R90861830990a48fa"/>
+    <p:sldId xmlns:r="http://schemas.openxmlformats.org/officeDocument/2006/relationships" id="261" r:id="R4e7fbb782cd14af4"/>
+    <p:sldId xmlns:r="http://schemas.openxmlformats.org/officeDocument/2006/relationships" id="262" r:id="R809a7812da8d4386"/>
+    <p:sldId xmlns:r="http://schemas.openxmlformats.org/officeDocument/2006/relationships" id="263" r:id="Rfa2439110bb84804"/>
+    <p:sldId xmlns:r="http://schemas.openxmlformats.org/officeDocument/2006/relationships" id="264" r:id="R7a8a26cfe62e4f6f"/>
   </p:sldIdLst>
   <p:sldSz cx="12192000" cy="6858000"/>
   <p:notesSz cx="6858000" cy="9144000"/>
@@ -1212,7 +1212,7 @@
   </p:cSld>
   <p:clrMap bg1="lt1" tx1="dk1" bg2="lt2" tx2="dk2" accent1="accent1" accent2="accent2" accent3="accent3" accent4="accent4" accent5="accent5" accent6="accent6" hlink="hlink" folHlink="folHlink"/>
   <p:sldLayoutIdLst>
-    <p:sldLayoutId xmlns:r="http://schemas.openxmlformats.org/officeDocument/2006/relationships" id="2147483649" r:id="R4250e296756c46aa"/>
+    <p:sldLayoutId xmlns:r="http://schemas.openxmlformats.org/officeDocument/2006/relationships" id="2147483649" r:id="R46d490dacac94c5a"/>
   </p:sldLayoutIdLst>
   <p:txStyles>
     <p:titleStyle>
@@ -9918,7 +9918,7 @@
                 <a:ea typeface="Arial Unicode MS"/>
                 <a:cs typeface="Arial Unicode MS"/>
               </a:rPr>
-              <a:t>payer -15000 · payee +15000 USDC</a:t>
+              <a:t>payer -0.015 · payee +0.015 USDC</a:t>
             </a:r>
           </a:p>
         </p:txBody>

</xml_diff>